<commit_message>
Corrected capitalization errors in presentation
</commit_message>
<xml_diff>
--- a/presentation/presentation.pptx
+++ b/presentation/presentation.pptx
@@ -1049,7 +1049,7 @@
                 <a:schemeClr val="bg1"/>
               </a:solidFill>
             </a:rPr>
-            <a:t>Persistence: Talks to the database and “Translates” between Java and SQL</a:t>
+            <a:t>Persistence: Talks to the database and “translates” between Java and SQL</a:t>
           </a:r>
         </a:p>
       </dgm:t>
@@ -1861,7 +1861,7 @@
                 <a:schemeClr val="bg1"/>
               </a:solidFill>
             </a:rPr>
-            <a:t>Persistence: Talks to the database and “Translates” between Java and SQL</a:t>
+            <a:t>Persistence: Talks to the database and “translates” between Java and SQL</a:t>
           </a:r>
         </a:p>
       </dsp:txBody>
@@ -12010,14 +12010,14 @@
           <a:p>
             <a:r>
               <a:rPr lang="en-US" dirty="0"/>
-              <a:t>Core Ledger uses Junit 5 and Mockito for positive and negative tests, verifying both that a method works with valid input and that it properly handles invalid input</a:t>
+              <a:t>Core Ledger uses JUnit 5 and Mockito for positive and negative tests, verifying both that a method works with valid input and that it properly handles invalid input</a:t>
             </a:r>
           </a:p>
           <a:p>
             <a:pPr lvl="1"/>
             <a:r>
               <a:rPr lang="en-US" dirty="0"/>
-              <a:t>Junit 5 enables unit tests and Mockito enables the mocking of objects</a:t>
+              <a:t>JUnit 5 enables unit tests and Mockito enables the mocking of objects</a:t>
             </a:r>
           </a:p>
           <a:p>
@@ -12346,7 +12346,7 @@
           <a:p>
             <a:r>
               <a:rPr lang="en-US" dirty="0"/>
-              <a:t>Junit 5 and Mockito: Testing</a:t>
+              <a:t>JUnit 5 and Mockito: Testing</a:t>
             </a:r>
           </a:p>
           <a:p>
@@ -12684,7 +12684,7 @@
             <p:ph idx="1"/>
             <p:extLst>
               <p:ext uri="{D42A27DB-BD31-4B8C-83A1-F6EECF244321}">
-                <p14:modId xmlns:p14="http://schemas.microsoft.com/office/powerpoint/2010/main" val="412615171"/>
+                <p14:modId xmlns:p14="http://schemas.microsoft.com/office/powerpoint/2010/main" val="668193984"/>
               </p:ext>
             </p:extLst>
           </p:nvPr>

</xml_diff>